<commit_message>
Renommer la section expériences en "PRINCIPALES EXPÉRIENCES PROFESSIONNELLES"
Nouvelle règle permanente : la section des expériences s'intitule
"PRINCIPALES EXPÉRIENCES PROFESSIONNELLES" (au lieu de "EXPÉRIENCE
PROFESSIONNELLE"), et "MAIN PROFESSIONAL EXPERIENCE" côté anglais pour
rester cohérent avec "MAIN AREAS OF EXPERTISE" et "MAIN REFERENCES".

- Libellé modifié dans renderer/i18n.py (PPTX) et renderer/preview_html.py
  (aperçu HTML) pour que tous les CV futurs l'appliquent automatiquement
- Les 28 CV existants ont été régénérés avec le nouveau libellé
- Les PPT de lots (lot1 à lot4) ont également été régénérés
- Vérifié visuellement : le libellé tient sur une seule ligne et n'a pas
  d'impact sur la mise en page (le budget de hauteur d'une section est
  constant), y compris sur les profils les plus denses

Co-Authored-By: Claude Opus 5 <noreply@anthropic.com>
Claude-Session: https://claude.ai/code/session_01P34Y9PqaSyqWxj7EA7cQyd
</commit_message>
<xml_diff>
--- a/outputs/A.A.D._conformite_distribution_assurance.pptx
+++ b/outputs/A.A.D._conformite_distribution_assurance.pptx
@@ -3861,7 +3861,7 @@
                 </a:solidFill>
                 <a:latin typeface="Alegreya Sans"/>
               </a:rPr>
-              <a:t>EXPÉRIENCE PROFESSIONNELLE</a:t>
+              <a:t>PRINCIPALES EXPÉRIENCES PROFESSIONNELLES</a:t>
             </a:r>
           </a:p>
           <a:p>
@@ -5049,7 +5049,7 @@
                 </a:solidFill>
                 <a:latin typeface="Alegreya Sans"/>
               </a:rPr>
-              <a:t>PROFESSIONAL EXPERIENCE</a:t>
+              <a:t>MAIN PROFESSIONAL EXPERIENCE</a:t>
             </a:r>
           </a:p>
           <a:p>

</xml_diff>